<commit_message>
Atualiza os slides de arquitetura para o padrao MVC
</commit_message>
<xml_diff>
--- a/Apresentacao_Backend_Assistente_Receitas.pptx
+++ b/Apresentacao_Backend_Assistente_Receitas.pptx
@@ -10202,7 +10202,7 @@
                   <a:schemeClr val="tx2"/>
                 </a:solidFill>
               </a:rPr>
-              <a:t>Arquitetura: o backend é o único caminho até o Gemini</a:t>
+              <a:t>Arquitetura MVC: o único caminho até o Gemini</a:t>
             </a:r>
             <a:endParaRPr lang="en-US" sz="3400" dirty="0"/>
           </a:p>
@@ -10379,7 +10379,7 @@
                   <a:schemeClr val="accent1"/>
                 </a:solidFill>
               </a:rPr>
-              <a:t>Backend · app.py (Flask) · :3001</a:t>
+              <a:t>Backend Flask · padrão MVC · :3001</a:t>
             </a:r>
             <a:endParaRPr lang="en-US" sz="1600" dirty="0"/>
           </a:p>
@@ -10444,7 +10444,7 @@
                   <a:schemeClr val="tx2"/>
                 </a:solidFill>
               </a:rPr>
-              <a:t>Rotas + CORS</a:t>
+              <a:t>Controller</a:t>
             </a:r>
             <a:endParaRPr lang="en-US" sz="1400" dirty="0"/>
           </a:p>
@@ -10458,7 +10458,7 @@
                   <a:schemeClr val="accent4"/>
                 </a:solidFill>
               </a:rPr>
-              <a:t>GET /, /api/status, POST /gerar</a:t>
+              <a:t>receita_controller.py · rotas</a:t>
             </a:r>
             <a:endParaRPr lang="en-US" sz="1400" dirty="0"/>
           </a:p>
@@ -10466,14 +10466,445 @@
       </p:sp>
       <p:sp>
         <p:nvSpPr>
-          <p:cNvPr id="9" name="Shape 7"/>
+          <p:cNvPr id="10" name="arq-int-1"/>
           <p:cNvSpPr/>
           <p:nvPr/>
         </p:nvSpPr>
         <p:spPr>
           <a:xfrm>
-            <a:off x="6080760" y="2715768"/>
-            <a:ext cx="0" cy="228600"/>
+            <a:off x="4297680" y="2944368"/>
+            <a:ext cx="3566160" cy="749808"/>
+          </a:xfrm>
+          <a:prstGeom prst="roundRect">
+            <a:avLst>
+              <a:gd name="adj" fmla="val 14634"/>
+            </a:avLst>
+          </a:prstGeom>
+          <a:solidFill>
+            <a:schemeClr val="bg2"/>
+          </a:solidFill>
+          <a:ln/>
+        </p:spPr>
+        <p:txBody>
+          <a:bodyPr/>
+          <a:lstStyle/>
+          <a:p>
+            <a:endParaRPr lang="pt-BR"/>
+          </a:p>
+        </p:txBody>
+      </p:sp>
+      <p:sp>
+        <p:nvSpPr>
+          <p:cNvPr id="11" name="Text 9"/>
+          <p:cNvSpPr txBox="1"/>
+          <p:nvPr/>
+        </p:nvSpPr>
+        <p:spPr>
+          <a:xfrm>
+            <a:off x="4480560" y="3035808"/>
+            <a:ext cx="3291840" cy="594360"/>
+          </a:xfrm>
+          <a:prstGeom prst="rect">
+            <a:avLst/>
+          </a:prstGeom>
+          <a:noFill/>
+          <a:ln/>
+        </p:spPr>
+        <p:txBody>
+          <a:bodyPr wrap="square" lIns="0" tIns="0" rIns="0" bIns="0" rtlCol="0" anchor="t"/>
+          <a:lstStyle/>
+          <a:p>
+            <a:pPr marL="0" indent="0">
+              <a:buNone/>
+            </a:pPr>
+            <a:r>
+              <a:rPr lang="en-US" sz="1500" b="1" dirty="0">
+                <a:solidFill>
+                  <a:schemeClr val="tx2"/>
+                </a:solidFill>
+              </a:rPr>
+              <a:t>View</a:t>
+            </a:r>
+            <a:endParaRPr lang="en-US" sz="1400" dirty="0"/>
+          </a:p>
+          <a:p>
+            <a:pPr marL="0" indent="0">
+              <a:buNone/>
+            </a:pPr>
+            <a:r>
+              <a:rPr lang="en-US" sz="1300" dirty="0">
+                <a:solidFill>
+                  <a:schemeClr val="accent4"/>
+                </a:solidFill>
+              </a:rPr>
+              <a:t>resposta_view.py · monta o JSON</a:t>
+            </a:r>
+            <a:endParaRPr lang="en-US" sz="1400" dirty="0"/>
+          </a:p>
+        </p:txBody>
+      </p:sp>
+      <p:sp>
+        <p:nvSpPr>
+          <p:cNvPr id="13" name="arq-int-2"/>
+          <p:cNvSpPr/>
+          <p:nvPr/>
+        </p:nvSpPr>
+        <p:spPr>
+          <a:xfrm>
+            <a:off x="4297680" y="3922776"/>
+            <a:ext cx="3566160" cy="749808"/>
+          </a:xfrm>
+          <a:prstGeom prst="roundRect">
+            <a:avLst>
+              <a:gd name="adj" fmla="val 14634"/>
+            </a:avLst>
+          </a:prstGeom>
+          <a:solidFill>
+            <a:schemeClr val="bg2"/>
+          </a:solidFill>
+          <a:ln/>
+        </p:spPr>
+        <p:txBody>
+          <a:bodyPr/>
+          <a:lstStyle/>
+          <a:p>
+            <a:endParaRPr lang="pt-BR"/>
+          </a:p>
+        </p:txBody>
+      </p:sp>
+      <p:sp>
+        <p:nvSpPr>
+          <p:cNvPr id="14" name="Text 12"/>
+          <p:cNvSpPr txBox="1"/>
+          <p:nvPr/>
+        </p:nvSpPr>
+        <p:spPr>
+          <a:xfrm>
+            <a:off x="4480560" y="4014216"/>
+            <a:ext cx="3291840" cy="594360"/>
+          </a:xfrm>
+          <a:prstGeom prst="rect">
+            <a:avLst/>
+          </a:prstGeom>
+          <a:noFill/>
+          <a:ln/>
+        </p:spPr>
+        <p:txBody>
+          <a:bodyPr wrap="square" lIns="0" tIns="0" rIns="0" bIns="0" rtlCol="0" anchor="t"/>
+          <a:lstStyle/>
+          <a:p>
+            <a:pPr marL="0" indent="0">
+              <a:buNone/>
+            </a:pPr>
+            <a:r>
+              <a:rPr lang="en-US" sz="1500" b="1" dirty="0">
+                <a:solidFill>
+                  <a:schemeClr val="tx2"/>
+                </a:solidFill>
+              </a:rPr>
+              <a:t>Model</a:t>
+            </a:r>
+            <a:endParaRPr lang="en-US" sz="1400" dirty="0"/>
+          </a:p>
+          <a:p>
+            <a:pPr marL="0" indent="0">
+              <a:buNone/>
+            </a:pPr>
+            <a:r>
+              <a:rPr lang="en-US" sz="1300" dirty="0">
+                <a:solidFill>
+                  <a:schemeClr val="accent4"/>
+                </a:solidFill>
+              </a:rPr>
+              <a:t>receita_model.py · regras e validação</a:t>
+            </a:r>
+            <a:endParaRPr lang="en-US" sz="1400" dirty="0"/>
+          </a:p>
+        </p:txBody>
+      </p:sp>
+      <p:sp>
+        <p:nvSpPr>
+          <p:cNvPr id="16" name="arq-int-3"/>
+          <p:cNvSpPr/>
+          <p:nvPr/>
+        </p:nvSpPr>
+        <p:spPr>
+          <a:xfrm>
+            <a:off x="4297680" y="4901184"/>
+            <a:ext cx="3566160" cy="749808"/>
+          </a:xfrm>
+          <a:prstGeom prst="roundRect">
+            <a:avLst>
+              <a:gd name="adj" fmla="val 14634"/>
+            </a:avLst>
+          </a:prstGeom>
+          <a:solidFill>
+            <a:schemeClr val="bg2"/>
+          </a:solidFill>
+          <a:ln/>
+        </p:spPr>
+        <p:txBody>
+          <a:bodyPr/>
+          <a:lstStyle/>
+          <a:p>
+            <a:endParaRPr lang="pt-BR"/>
+          </a:p>
+        </p:txBody>
+      </p:sp>
+      <p:sp>
+        <p:nvSpPr>
+          <p:cNvPr id="17" name="Text 15"/>
+          <p:cNvSpPr txBox="1"/>
+          <p:nvPr/>
+        </p:nvSpPr>
+        <p:spPr>
+          <a:xfrm>
+            <a:off x="4480560" y="4992624"/>
+            <a:ext cx="3291840" cy="594360"/>
+          </a:xfrm>
+          <a:prstGeom prst="rect">
+            <a:avLst/>
+          </a:prstGeom>
+          <a:noFill/>
+          <a:ln/>
+        </p:spPr>
+        <p:txBody>
+          <a:bodyPr wrap="square" lIns="0" tIns="0" rIns="0" bIns="0" rtlCol="0" anchor="t"/>
+          <a:lstStyle/>
+          <a:p>
+            <a:pPr marL="0" indent="0">
+              <a:buNone/>
+            </a:pPr>
+            <a:r>
+              <a:rPr lang="en-US" sz="1500" b="1" dirty="0">
+                <a:solidFill>
+                  <a:schemeClr val="tx2"/>
+                </a:solidFill>
+              </a:rPr>
+              <a:t>Model · IA</a:t>
+            </a:r>
+            <a:endParaRPr lang="en-US" sz="1400" dirty="0"/>
+          </a:p>
+          <a:p>
+            <a:pPr marL="0" indent="0">
+              <a:buNone/>
+            </a:pPr>
+            <a:r>
+              <a:rPr lang="en-US" sz="1300" dirty="0">
+                <a:solidFill>
+                  <a:schemeClr val="accent4"/>
+                </a:solidFill>
+              </a:rPr>
+              <a:t>prompt, Gemini e modelo reserva</a:t>
+            </a:r>
+            <a:endParaRPr lang="en-US" sz="1400" dirty="0"/>
+          </a:p>
+        </p:txBody>
+      </p:sp>
+      <p:sp>
+        <p:nvSpPr>
+          <p:cNvPr id="18" name="arq-gemini"/>
+          <p:cNvSpPr/>
+          <p:nvPr/>
+        </p:nvSpPr>
+        <p:spPr>
+          <a:xfrm>
+            <a:off x="8961120" y="4023360"/>
+            <a:ext cx="2651760" cy="1920240"/>
+          </a:xfrm>
+          <a:prstGeom prst="roundRect">
+            <a:avLst>
+              <a:gd name="adj" fmla="val 5714"/>
+            </a:avLst>
+          </a:prstGeom>
+          <a:solidFill>
+            <a:schemeClr val="bg2"/>
+          </a:solidFill>
+          <a:ln/>
+        </p:spPr>
+        <p:txBody>
+          <a:bodyPr/>
+          <a:lstStyle/>
+          <a:p>
+            <a:endParaRPr lang="pt-BR"/>
+          </a:p>
+        </p:txBody>
+      </p:sp>
+      <p:sp>
+        <p:nvSpPr>
+          <p:cNvPr id="19" name="Text 17"/>
+          <p:cNvSpPr txBox="1"/>
+          <p:nvPr/>
+        </p:nvSpPr>
+        <p:spPr>
+          <a:xfrm>
+            <a:off x="9189720" y="4206240"/>
+            <a:ext cx="2286000" cy="1645920"/>
+          </a:xfrm>
+          <a:prstGeom prst="rect">
+            <a:avLst/>
+          </a:prstGeom>
+          <a:noFill/>
+          <a:ln/>
+        </p:spPr>
+        <p:txBody>
+          <a:bodyPr wrap="square" lIns="0" tIns="0" rIns="0" bIns="0" rtlCol="0" anchor="t"/>
+          <a:lstStyle/>
+          <a:p>
+            <a:pPr marL="0" indent="0">
+              <a:buNone/>
+            </a:pPr>
+            <a:r>
+              <a:rPr lang="en-US" sz="1800" b="1" dirty="0">
+                <a:solidFill>
+                  <a:schemeClr val="tx2"/>
+                </a:solidFill>
+              </a:rPr>
+              <a:t>Google Gemini</a:t>
+            </a:r>
+            <a:endParaRPr lang="en-US" sz="1400" dirty="0"/>
+          </a:p>
+          <a:p>
+            <a:pPr marL="0" indent="0">
+              <a:buNone/>
+            </a:pPr>
+            <a:r>
+              <a:rPr lang="en-US" sz="1400" dirty="0">
+                <a:solidFill>
+                  <a:schemeClr val="tx1"/>
+                </a:solidFill>
+              </a:rPr>
+              <a:t>gemini-3.8-flash</a:t>
+            </a:r>
+            <a:endParaRPr lang="en-US" sz="1400" dirty="0"/>
+          </a:p>
+          <a:p>
+            <a:pPr marL="0" indent="0">
+              <a:buNone/>
+            </a:pPr>
+            <a:r>
+              <a:rPr lang="en-US" sz="1400" dirty="0">
+                <a:solidFill>
+                  <a:schemeClr val="tx1"/>
+                </a:solidFill>
+              </a:rPr>
+              <a:t>gemini-3.1-flash-lite</a:t>
+            </a:r>
+            <a:endParaRPr lang="en-US" sz="1400" dirty="0"/>
+          </a:p>
+          <a:p>
+            <a:pPr marL="0" indent="0">
+              <a:buNone/>
+            </a:pPr>
+            <a:r>
+              <a:rPr lang="en-US" sz="1400" dirty="0" err="1">
+                <a:solidFill>
+                  <a:schemeClr val="accent4"/>
+                </a:solidFill>
+              </a:rPr>
+              <a:t>Resposta</a:t>
+            </a:r>
+            <a:r>
+              <a:rPr lang="en-US" sz="1400" dirty="0">
+                <a:solidFill>
+                  <a:schemeClr val="accent4"/>
+                </a:solidFill>
+              </a:rPr>
+              <a:t> em JSON</a:t>
+            </a:r>
+            <a:endParaRPr lang="en-US" sz="1400" dirty="0"/>
+          </a:p>
+        </p:txBody>
+      </p:sp>
+      <p:sp>
+        <p:nvSpPr>
+          <p:cNvPr id="20" name="arq-env"/>
+          <p:cNvSpPr/>
+          <p:nvPr/>
+        </p:nvSpPr>
+        <p:spPr>
+          <a:xfrm>
+            <a:off x="548640" y="5029200"/>
+            <a:ext cx="2468880" cy="914400"/>
+          </a:xfrm>
+          <a:prstGeom prst="roundRect">
+            <a:avLst>
+              <a:gd name="adj" fmla="val 12000"/>
+            </a:avLst>
+          </a:prstGeom>
+          <a:solidFill>
+            <a:schemeClr val="bg2"/>
+          </a:solidFill>
+          <a:ln/>
+        </p:spPr>
+        <p:txBody>
+          <a:bodyPr/>
+          <a:lstStyle/>
+          <a:p>
+            <a:endParaRPr lang="pt-BR"/>
+          </a:p>
+        </p:txBody>
+      </p:sp>
+      <p:sp>
+        <p:nvSpPr>
+          <p:cNvPr id="21" name="Text 19"/>
+          <p:cNvSpPr txBox="1"/>
+          <p:nvPr/>
+        </p:nvSpPr>
+        <p:spPr>
+          <a:xfrm>
+            <a:off x="777240" y="5166360"/>
+            <a:ext cx="2103120" cy="685800"/>
+          </a:xfrm>
+          <a:prstGeom prst="rect">
+            <a:avLst/>
+          </a:prstGeom>
+          <a:noFill/>
+          <a:ln/>
+        </p:spPr>
+        <p:txBody>
+          <a:bodyPr wrap="square" lIns="0" tIns="0" rIns="0" bIns="0" rtlCol="0" anchor="t"/>
+          <a:lstStyle/>
+          <a:p>
+            <a:pPr marL="0" indent="0">
+              <a:buNone/>
+            </a:pPr>
+            <a:r>
+              <a:rPr lang="en-US" sz="1500" b="1" dirty="0">
+                <a:solidFill>
+                  <a:schemeClr val="tx2"/>
+                </a:solidFill>
+              </a:rPr>
+              <a:t>.env (só no servidor)</a:t>
+            </a:r>
+            <a:endParaRPr lang="en-US" sz="1400" dirty="0"/>
+          </a:p>
+          <a:p>
+            <a:pPr marL="0" indent="0">
+              <a:buNone/>
+            </a:pPr>
+            <a:r>
+              <a:rPr lang="en-US" sz="1300" dirty="0">
+                <a:solidFill>
+                  <a:schemeClr val="accent4"/>
+                </a:solidFill>
+              </a:rPr>
+              <a:t>GEMINI_API_KEY, PORT</a:t>
+            </a:r>
+            <a:endParaRPr lang="en-US" sz="1400" dirty="0"/>
+          </a:p>
+        </p:txBody>
+      </p:sp>
+      <p:sp>
+        <p:nvSpPr>
+          <p:cNvPr id="22" name="Shape 20"/>
+          <p:cNvSpPr/>
+          <p:nvPr/>
+        </p:nvSpPr>
+        <p:spPr>
+          <a:xfrm>
+            <a:off x="3017520" y="2194560"/>
+            <a:ext cx="1280160" cy="0"/>
           </a:xfrm>
           <a:prstGeom prst="line">
             <a:avLst/>
@@ -10497,93 +10928,14 @@
       </p:sp>
       <p:sp>
         <p:nvSpPr>
-          <p:cNvPr id="10" name="arq-int-1"/>
+          <p:cNvPr id="23" name="Shape 21"/>
           <p:cNvSpPr/>
           <p:nvPr/>
         </p:nvSpPr>
         <p:spPr>
-          <a:xfrm>
-            <a:off x="4297680" y="2944368"/>
-            <a:ext cx="3566160" cy="749808"/>
-          </a:xfrm>
-          <a:prstGeom prst="roundRect">
-            <a:avLst>
-              <a:gd name="adj" fmla="val 14634"/>
-            </a:avLst>
-          </a:prstGeom>
-          <a:solidFill>
-            <a:schemeClr val="bg2"/>
-          </a:solidFill>
-          <a:ln/>
-        </p:spPr>
-        <p:txBody>
-          <a:bodyPr/>
-          <a:lstStyle/>
-          <a:p>
-            <a:endParaRPr lang="pt-BR"/>
-          </a:p>
-        </p:txBody>
-      </p:sp>
-      <p:sp>
-        <p:nvSpPr>
-          <p:cNvPr id="11" name="Text 9"/>
-          <p:cNvSpPr txBox="1"/>
-          <p:nvPr/>
-        </p:nvSpPr>
-        <p:spPr>
-          <a:xfrm>
-            <a:off x="4480560" y="3035808"/>
-            <a:ext cx="3291840" cy="594360"/>
-          </a:xfrm>
-          <a:prstGeom prst="rect">
-            <a:avLst/>
-          </a:prstGeom>
-          <a:noFill/>
-          <a:ln/>
-        </p:spPr>
-        <p:txBody>
-          <a:bodyPr wrap="square" lIns="0" tIns="0" rIns="0" bIns="0" rtlCol="0" anchor="t"/>
-          <a:lstStyle/>
-          <a:p>
-            <a:pPr marL="0" indent="0">
-              <a:buNone/>
-            </a:pPr>
-            <a:r>
-              <a:rPr lang="en-US" sz="1500" b="1" dirty="0">
-                <a:solidFill>
-                  <a:schemeClr val="tx2"/>
-                </a:solidFill>
-              </a:rPr>
-              <a:t>Validação</a:t>
-            </a:r>
-            <a:endParaRPr lang="en-US" sz="1400" dirty="0"/>
-          </a:p>
-          <a:p>
-            <a:pPr marL="0" indent="0">
-              <a:buNone/>
-            </a:pPr>
-            <a:r>
-              <a:rPr lang="en-US" sz="1300" dirty="0">
-                <a:solidFill>
-                  <a:schemeClr val="accent4"/>
-                </a:solidFill>
-              </a:rPr>
-              <a:t>Ingredientes obrigatórios, padrões</a:t>
-            </a:r>
-            <a:endParaRPr lang="en-US" sz="1400" dirty="0"/>
-          </a:p>
-        </p:txBody>
-      </p:sp>
-      <p:sp>
-        <p:nvSpPr>
-          <p:cNvPr id="12" name="Shape 10"/>
-          <p:cNvSpPr/>
-          <p:nvPr/>
-        </p:nvSpPr>
-        <p:spPr>
-          <a:xfrm>
-            <a:off x="6080760" y="3694176"/>
-            <a:ext cx="0" cy="228600"/>
+          <a:xfrm flipH="1">
+            <a:off x="3017520" y="2560320"/>
+            <a:ext cx="1280160" cy="0"/>
           </a:xfrm>
           <a:prstGeom prst="line">
             <a:avLst/>
@@ -10607,93 +10959,86 @@
       </p:sp>
       <p:sp>
         <p:nvSpPr>
-          <p:cNvPr id="13" name="arq-int-2"/>
+          <p:cNvPr id="24" name="Text 22"/>
+          <p:cNvSpPr txBox="1"/>
+          <p:nvPr/>
+        </p:nvSpPr>
+        <p:spPr>
+          <a:xfrm>
+            <a:off x="3017520" y="1828800"/>
+            <a:ext cx="1005840" cy="274320"/>
+          </a:xfrm>
+          <a:prstGeom prst="rect">
+            <a:avLst/>
+          </a:prstGeom>
+          <a:noFill/>
+          <a:ln/>
+        </p:spPr>
+        <p:txBody>
+          <a:bodyPr wrap="square" lIns="0" tIns="0" rIns="0" bIns="0" rtlCol="0" anchor="t"/>
+          <a:lstStyle/>
+          <a:p>
+            <a:pPr marL="0" indent="0" algn="ctr">
+              <a:buNone/>
+            </a:pPr>
+            <a:r>
+              <a:rPr lang="en-US" sz="1100" dirty="0">
+                <a:solidFill>
+                  <a:schemeClr val="accent4"/>
+                </a:solidFill>
+              </a:rPr>
+              <a:t>pedido JSON</a:t>
+            </a:r>
+            <a:endParaRPr lang="en-US" sz="1100" dirty="0"/>
+          </a:p>
+        </p:txBody>
+      </p:sp>
+      <p:sp>
+        <p:nvSpPr>
+          <p:cNvPr id="25" name="Text 23"/>
+          <p:cNvSpPr txBox="1"/>
+          <p:nvPr/>
+        </p:nvSpPr>
+        <p:spPr>
+          <a:xfrm>
+            <a:off x="3017520" y="2651760"/>
+            <a:ext cx="1005840" cy="274320"/>
+          </a:xfrm>
+          <a:prstGeom prst="rect">
+            <a:avLst/>
+          </a:prstGeom>
+          <a:noFill/>
+          <a:ln/>
+        </p:spPr>
+        <p:txBody>
+          <a:bodyPr wrap="square" lIns="0" tIns="0" rIns="0" bIns="0" rtlCol="0" anchor="t"/>
+          <a:lstStyle/>
+          <a:p>
+            <a:pPr marL="0" indent="0" algn="ctr">
+              <a:buNone/>
+            </a:pPr>
+            <a:r>
+              <a:rPr lang="en-US" sz="1100" dirty="0">
+                <a:solidFill>
+                  <a:schemeClr val="accent4"/>
+                </a:solidFill>
+              </a:rPr>
+              <a:t>receita JSON</a:t>
+            </a:r>
+            <a:endParaRPr lang="en-US" sz="1100" dirty="0"/>
+          </a:p>
+        </p:txBody>
+      </p:sp>
+      <p:sp>
+        <p:nvSpPr>
+          <p:cNvPr id="26" name="Shape 24"/>
           <p:cNvSpPr/>
           <p:nvPr/>
         </p:nvSpPr>
         <p:spPr>
           <a:xfrm>
-            <a:off x="4297680" y="3922776"/>
-            <a:ext cx="3566160" cy="749808"/>
-          </a:xfrm>
-          <a:prstGeom prst="roundRect">
-            <a:avLst>
-              <a:gd name="adj" fmla="val 14634"/>
-            </a:avLst>
-          </a:prstGeom>
-          <a:solidFill>
-            <a:schemeClr val="bg2"/>
-          </a:solidFill>
-          <a:ln/>
-        </p:spPr>
-        <p:txBody>
-          <a:bodyPr/>
-          <a:lstStyle/>
-          <a:p>
-            <a:endParaRPr lang="pt-BR"/>
-          </a:p>
-        </p:txBody>
-      </p:sp>
-      <p:sp>
-        <p:nvSpPr>
-          <p:cNvPr id="14" name="Text 12"/>
-          <p:cNvSpPr txBox="1"/>
-          <p:nvPr/>
-        </p:nvSpPr>
-        <p:spPr>
-          <a:xfrm>
-            <a:off x="4480560" y="4014216"/>
-            <a:ext cx="3291840" cy="594360"/>
-          </a:xfrm>
-          <a:prstGeom prst="rect">
-            <a:avLst/>
-          </a:prstGeom>
-          <a:noFill/>
-          <a:ln/>
-        </p:spPr>
-        <p:txBody>
-          <a:bodyPr wrap="square" lIns="0" tIns="0" rIns="0" bIns="0" rtlCol="0" anchor="t"/>
-          <a:lstStyle/>
-          <a:p>
-            <a:pPr marL="0" indent="0">
-              <a:buNone/>
-            </a:pPr>
-            <a:r>
-              <a:rPr lang="en-US" sz="1500" b="1" dirty="0">
-                <a:solidFill>
-                  <a:schemeClr val="tx2"/>
-                </a:solidFill>
-              </a:rPr>
-              <a:t>Prompt</a:t>
-            </a:r>
-            <a:endParaRPr lang="en-US" sz="1400" dirty="0"/>
-          </a:p>
-          <a:p>
-            <a:pPr marL="0" indent="0">
-              <a:buNone/>
-            </a:pPr>
-            <a:r>
-              <a:rPr lang="en-US" sz="1300" dirty="0">
-                <a:solidFill>
-                  <a:schemeClr val="accent4"/>
-                </a:solidFill>
-              </a:rPr>
-              <a:t>Persona + regras + molde JSON</a:t>
-            </a:r>
-            <a:endParaRPr lang="en-US" sz="1400" dirty="0"/>
-          </a:p>
-        </p:txBody>
-      </p:sp>
-      <p:sp>
-        <p:nvSpPr>
-          <p:cNvPr id="15" name="Shape 13"/>
-          <p:cNvSpPr/>
-          <p:nvPr/>
-        </p:nvSpPr>
-        <p:spPr>
-          <a:xfrm>
-            <a:off x="6080760" y="4672584"/>
-            <a:ext cx="0" cy="228600"/>
+            <a:off x="3017520" y="5486400"/>
+            <a:ext cx="1005840" cy="0"/>
           </a:xfrm>
           <a:prstGeom prst="line">
             <a:avLst/>
@@ -10717,287 +11062,14 @@
       </p:sp>
       <p:sp>
         <p:nvSpPr>
-          <p:cNvPr id="16" name="arq-int-3"/>
+          <p:cNvPr id="27" name="Shape 25"/>
           <p:cNvSpPr/>
           <p:nvPr/>
         </p:nvSpPr>
         <p:spPr>
           <a:xfrm>
-            <a:off x="4297680" y="4901184"/>
-            <a:ext cx="3566160" cy="749808"/>
-          </a:xfrm>
-          <a:prstGeom prst="roundRect">
-            <a:avLst>
-              <a:gd name="adj" fmla="val 14634"/>
-            </a:avLst>
-          </a:prstGeom>
-          <a:solidFill>
-            <a:schemeClr val="bg2"/>
-          </a:solidFill>
-          <a:ln/>
-        </p:spPr>
-        <p:txBody>
-          <a:bodyPr/>
-          <a:lstStyle/>
-          <a:p>
-            <a:endParaRPr lang="pt-BR"/>
-          </a:p>
-        </p:txBody>
-      </p:sp>
-      <p:sp>
-        <p:nvSpPr>
-          <p:cNvPr id="17" name="Text 15"/>
-          <p:cNvSpPr txBox="1"/>
-          <p:nvPr/>
-        </p:nvSpPr>
-        <p:spPr>
-          <a:xfrm>
-            <a:off x="4480560" y="4992624"/>
-            <a:ext cx="3291840" cy="594360"/>
-          </a:xfrm>
-          <a:prstGeom prst="rect">
-            <a:avLst/>
-          </a:prstGeom>
-          <a:noFill/>
-          <a:ln/>
-        </p:spPr>
-        <p:txBody>
-          <a:bodyPr wrap="square" lIns="0" tIns="0" rIns="0" bIns="0" rtlCol="0" anchor="t"/>
-          <a:lstStyle/>
-          <a:p>
-            <a:pPr marL="0" indent="0">
-              <a:buNone/>
-            </a:pPr>
-            <a:r>
-              <a:rPr lang="en-US" sz="1500" b="1" dirty="0">
-                <a:solidFill>
-                  <a:schemeClr val="tx2"/>
-                </a:solidFill>
-              </a:rPr>
-              <a:t>chamar_modelo()</a:t>
-            </a:r>
-            <a:endParaRPr lang="en-US" sz="1400" dirty="0"/>
-          </a:p>
-          <a:p>
-            <a:pPr marL="0" indent="0">
-              <a:buNone/>
-            </a:pPr>
-            <a:r>
-              <a:rPr lang="en-US" sz="1300" dirty="0">
-                <a:solidFill>
-                  <a:schemeClr val="accent4"/>
-                </a:solidFill>
-              </a:rPr>
-              <a:t>Principal → reserva, lê o JSON</a:t>
-            </a:r>
-            <a:endParaRPr lang="en-US" sz="1400" dirty="0"/>
-          </a:p>
-        </p:txBody>
-      </p:sp>
-      <p:sp>
-        <p:nvSpPr>
-          <p:cNvPr id="18" name="arq-gemini"/>
-          <p:cNvSpPr/>
-          <p:nvPr/>
-        </p:nvSpPr>
-        <p:spPr>
-          <a:xfrm>
-            <a:off x="8961120" y="4023360"/>
-            <a:ext cx="2651760" cy="1920240"/>
-          </a:xfrm>
-          <a:prstGeom prst="roundRect">
-            <a:avLst>
-              <a:gd name="adj" fmla="val 5714"/>
-            </a:avLst>
-          </a:prstGeom>
-          <a:solidFill>
-            <a:schemeClr val="bg2"/>
-          </a:solidFill>
-          <a:ln/>
-        </p:spPr>
-        <p:txBody>
-          <a:bodyPr/>
-          <a:lstStyle/>
-          <a:p>
-            <a:endParaRPr lang="pt-BR"/>
-          </a:p>
-        </p:txBody>
-      </p:sp>
-      <p:sp>
-        <p:nvSpPr>
-          <p:cNvPr id="19" name="Text 17"/>
-          <p:cNvSpPr txBox="1"/>
-          <p:nvPr/>
-        </p:nvSpPr>
-        <p:spPr>
-          <a:xfrm>
-            <a:off x="9189720" y="4206240"/>
-            <a:ext cx="2286000" cy="1645920"/>
-          </a:xfrm>
-          <a:prstGeom prst="rect">
-            <a:avLst/>
-          </a:prstGeom>
-          <a:noFill/>
-          <a:ln/>
-        </p:spPr>
-        <p:txBody>
-          <a:bodyPr wrap="square" lIns="0" tIns="0" rIns="0" bIns="0" rtlCol="0" anchor="t"/>
-          <a:lstStyle/>
-          <a:p>
-            <a:pPr marL="0" indent="0">
-              <a:buNone/>
-            </a:pPr>
-            <a:r>
-              <a:rPr lang="en-US" sz="1800" b="1" dirty="0">
-                <a:solidFill>
-                  <a:schemeClr val="tx2"/>
-                </a:solidFill>
-              </a:rPr>
-              <a:t>Google Gemini</a:t>
-            </a:r>
-            <a:endParaRPr lang="en-US" sz="1400" dirty="0"/>
-          </a:p>
-          <a:p>
-            <a:pPr marL="0" indent="0">
-              <a:buNone/>
-            </a:pPr>
-            <a:r>
-              <a:rPr lang="en-US" sz="1400" dirty="0">
-                <a:solidFill>
-                  <a:schemeClr val="tx1"/>
-                </a:solidFill>
-              </a:rPr>
-              <a:t>gemini-3.8-flash</a:t>
-            </a:r>
-            <a:endParaRPr lang="en-US" sz="1400" dirty="0"/>
-          </a:p>
-          <a:p>
-            <a:pPr marL="0" indent="0">
-              <a:buNone/>
-            </a:pPr>
-            <a:r>
-              <a:rPr lang="en-US" sz="1400" dirty="0">
-                <a:solidFill>
-                  <a:schemeClr val="tx1"/>
-                </a:solidFill>
-              </a:rPr>
-              <a:t>gemini-3.1-flash-lite</a:t>
-            </a:r>
-            <a:endParaRPr lang="en-US" sz="1400" dirty="0"/>
-          </a:p>
-          <a:p>
-            <a:pPr marL="0" indent="0">
-              <a:buNone/>
-            </a:pPr>
-            <a:r>
-              <a:rPr lang="en-US" sz="1400" dirty="0" err="1">
-                <a:solidFill>
-                  <a:schemeClr val="accent4"/>
-                </a:solidFill>
-              </a:rPr>
-              <a:t>Resposta</a:t>
-            </a:r>
-            <a:r>
-              <a:rPr lang="en-US" sz="1400" dirty="0">
-                <a:solidFill>
-                  <a:schemeClr val="accent4"/>
-                </a:solidFill>
-              </a:rPr>
-              <a:t> em JSON</a:t>
-            </a:r>
-            <a:endParaRPr lang="en-US" sz="1400" dirty="0"/>
-          </a:p>
-        </p:txBody>
-      </p:sp>
-      <p:sp>
-        <p:nvSpPr>
-          <p:cNvPr id="20" name="arq-env"/>
-          <p:cNvSpPr/>
-          <p:nvPr/>
-        </p:nvSpPr>
-        <p:spPr>
-          <a:xfrm>
-            <a:off x="548640" y="5029200"/>
-            <a:ext cx="2468880" cy="914400"/>
-          </a:xfrm>
-          <a:prstGeom prst="roundRect">
-            <a:avLst>
-              <a:gd name="adj" fmla="val 12000"/>
-            </a:avLst>
-          </a:prstGeom>
-          <a:solidFill>
-            <a:schemeClr val="bg2"/>
-          </a:solidFill>
-          <a:ln/>
-        </p:spPr>
-        <p:txBody>
-          <a:bodyPr/>
-          <a:lstStyle/>
-          <a:p>
-            <a:endParaRPr lang="pt-BR"/>
-          </a:p>
-        </p:txBody>
-      </p:sp>
-      <p:sp>
-        <p:nvSpPr>
-          <p:cNvPr id="21" name="Text 19"/>
-          <p:cNvSpPr txBox="1"/>
-          <p:nvPr/>
-        </p:nvSpPr>
-        <p:spPr>
-          <a:xfrm>
-            <a:off x="777240" y="5166360"/>
-            <a:ext cx="2103120" cy="685800"/>
-          </a:xfrm>
-          <a:prstGeom prst="rect">
-            <a:avLst/>
-          </a:prstGeom>
-          <a:noFill/>
-          <a:ln/>
-        </p:spPr>
-        <p:txBody>
-          <a:bodyPr wrap="square" lIns="0" tIns="0" rIns="0" bIns="0" rtlCol="0" anchor="t"/>
-          <a:lstStyle/>
-          <a:p>
-            <a:pPr marL="0" indent="0">
-              <a:buNone/>
-            </a:pPr>
-            <a:r>
-              <a:rPr lang="en-US" sz="1500" b="1" dirty="0">
-                <a:solidFill>
-                  <a:schemeClr val="tx2"/>
-                </a:solidFill>
-              </a:rPr>
-              <a:t>.env (só no servidor)</a:t>
-            </a:r>
-            <a:endParaRPr lang="en-US" sz="1400" dirty="0"/>
-          </a:p>
-          <a:p>
-            <a:pPr marL="0" indent="0">
-              <a:buNone/>
-            </a:pPr>
-            <a:r>
-              <a:rPr lang="en-US" sz="1300" dirty="0">
-                <a:solidFill>
-                  <a:schemeClr val="accent4"/>
-                </a:solidFill>
-              </a:rPr>
-              <a:t>GEMINI_API_KEY, PORT</a:t>
-            </a:r>
-            <a:endParaRPr lang="en-US" sz="1400" dirty="0"/>
-          </a:p>
-        </p:txBody>
-      </p:sp>
-      <p:sp>
-        <p:nvSpPr>
-          <p:cNvPr id="22" name="Shape 20"/>
-          <p:cNvSpPr/>
-          <p:nvPr/>
-        </p:nvSpPr>
-        <p:spPr>
-          <a:xfrm>
-            <a:off x="3017520" y="2194560"/>
-            <a:ext cx="1280160" cy="0"/>
+            <a:off x="7863840" y="4846320"/>
+            <a:ext cx="1097280" cy="0"/>
           </a:xfrm>
           <a:prstGeom prst="line">
             <a:avLst/>
@@ -11021,14 +11093,14 @@
       </p:sp>
       <p:sp>
         <p:nvSpPr>
-          <p:cNvPr id="23" name="Shape 21"/>
+          <p:cNvPr id="28" name="Shape 26"/>
           <p:cNvSpPr/>
           <p:nvPr/>
         </p:nvSpPr>
         <p:spPr>
           <a:xfrm flipH="1">
-            <a:off x="3017520" y="2560320"/>
-            <a:ext cx="1280160" cy="0"/>
+            <a:off x="7863840" y="5212080"/>
+            <a:ext cx="1097280" cy="0"/>
           </a:xfrm>
           <a:prstGeom prst="line">
             <a:avLst/>
@@ -11052,171 +11124,6 @@
       </p:sp>
       <p:sp>
         <p:nvSpPr>
-          <p:cNvPr id="24" name="Text 22"/>
-          <p:cNvSpPr txBox="1"/>
-          <p:nvPr/>
-        </p:nvSpPr>
-        <p:spPr>
-          <a:xfrm>
-            <a:off x="3017520" y="1828800"/>
-            <a:ext cx="1005840" cy="274320"/>
-          </a:xfrm>
-          <a:prstGeom prst="rect">
-            <a:avLst/>
-          </a:prstGeom>
-          <a:noFill/>
-          <a:ln/>
-        </p:spPr>
-        <p:txBody>
-          <a:bodyPr wrap="square" lIns="0" tIns="0" rIns="0" bIns="0" rtlCol="0" anchor="t"/>
-          <a:lstStyle/>
-          <a:p>
-            <a:pPr marL="0" indent="0" algn="ctr">
-              <a:buNone/>
-            </a:pPr>
-            <a:r>
-              <a:rPr lang="en-US" sz="1100" dirty="0">
-                <a:solidFill>
-                  <a:schemeClr val="accent4"/>
-                </a:solidFill>
-              </a:rPr>
-              <a:t>pedido JSON</a:t>
-            </a:r>
-            <a:endParaRPr lang="en-US" sz="1100" dirty="0"/>
-          </a:p>
-        </p:txBody>
-      </p:sp>
-      <p:sp>
-        <p:nvSpPr>
-          <p:cNvPr id="25" name="Text 23"/>
-          <p:cNvSpPr txBox="1"/>
-          <p:nvPr/>
-        </p:nvSpPr>
-        <p:spPr>
-          <a:xfrm>
-            <a:off x="3017520" y="2651760"/>
-            <a:ext cx="1005840" cy="274320"/>
-          </a:xfrm>
-          <a:prstGeom prst="rect">
-            <a:avLst/>
-          </a:prstGeom>
-          <a:noFill/>
-          <a:ln/>
-        </p:spPr>
-        <p:txBody>
-          <a:bodyPr wrap="square" lIns="0" tIns="0" rIns="0" bIns="0" rtlCol="0" anchor="t"/>
-          <a:lstStyle/>
-          <a:p>
-            <a:pPr marL="0" indent="0" algn="ctr">
-              <a:buNone/>
-            </a:pPr>
-            <a:r>
-              <a:rPr lang="en-US" sz="1100" dirty="0">
-                <a:solidFill>
-                  <a:schemeClr val="accent4"/>
-                </a:solidFill>
-              </a:rPr>
-              <a:t>receita JSON</a:t>
-            </a:r>
-            <a:endParaRPr lang="en-US" sz="1100" dirty="0"/>
-          </a:p>
-        </p:txBody>
-      </p:sp>
-      <p:sp>
-        <p:nvSpPr>
-          <p:cNvPr id="26" name="Shape 24"/>
-          <p:cNvSpPr/>
-          <p:nvPr/>
-        </p:nvSpPr>
-        <p:spPr>
-          <a:xfrm>
-            <a:off x="3017520" y="5486400"/>
-            <a:ext cx="1005840" cy="0"/>
-          </a:xfrm>
-          <a:prstGeom prst="line">
-            <a:avLst/>
-          </a:prstGeom>
-          <a:noFill/>
-          <a:ln w="22225">
-            <a:solidFill>
-              <a:schemeClr val="accent6"/>
-            </a:solidFill>
-            <a:prstDash val="solid"/>
-            <a:tailEnd type="triangle"/>
-          </a:ln>
-        </p:spPr>
-        <p:txBody>
-          <a:bodyPr/>
-          <a:lstStyle/>
-          <a:p>
-            <a:endParaRPr lang="pt-BR"/>
-          </a:p>
-        </p:txBody>
-      </p:sp>
-      <p:sp>
-        <p:nvSpPr>
-          <p:cNvPr id="27" name="Shape 25"/>
-          <p:cNvSpPr/>
-          <p:nvPr/>
-        </p:nvSpPr>
-        <p:spPr>
-          <a:xfrm>
-            <a:off x="7863840" y="4846320"/>
-            <a:ext cx="1097280" cy="0"/>
-          </a:xfrm>
-          <a:prstGeom prst="line">
-            <a:avLst/>
-          </a:prstGeom>
-          <a:noFill/>
-          <a:ln w="22225">
-            <a:solidFill>
-              <a:schemeClr val="accent6"/>
-            </a:solidFill>
-            <a:prstDash val="solid"/>
-            <a:tailEnd type="triangle"/>
-          </a:ln>
-        </p:spPr>
-        <p:txBody>
-          <a:bodyPr/>
-          <a:lstStyle/>
-          <a:p>
-            <a:endParaRPr lang="pt-BR"/>
-          </a:p>
-        </p:txBody>
-      </p:sp>
-      <p:sp>
-        <p:nvSpPr>
-          <p:cNvPr id="28" name="Shape 26"/>
-          <p:cNvSpPr/>
-          <p:nvPr/>
-        </p:nvSpPr>
-        <p:spPr>
-          <a:xfrm flipH="1">
-            <a:off x="7863840" y="5212080"/>
-            <a:ext cx="1097280" cy="0"/>
-          </a:xfrm>
-          <a:prstGeom prst="line">
-            <a:avLst/>
-          </a:prstGeom>
-          <a:noFill/>
-          <a:ln w="22225">
-            <a:solidFill>
-              <a:schemeClr val="accent6"/>
-            </a:solidFill>
-            <a:prstDash val="solid"/>
-            <a:tailEnd type="triangle"/>
-          </a:ln>
-        </p:spPr>
-        <p:txBody>
-          <a:bodyPr/>
-          <a:lstStyle/>
-          <a:p>
-            <a:endParaRPr lang="pt-BR"/>
-          </a:p>
-        </p:txBody>
-      </p:sp>
-      <p:sp>
-        <p:nvSpPr>
           <p:cNvPr id="29" name="Text 27"/>
           <p:cNvSpPr txBox="1"/>
           <p:nvPr/>
@@ -11317,7 +11224,7 @@
                   <a:schemeClr val="accent4"/>
                 </a:solidFill>
               </a:rPr>
-              <a:t>API REST stateless: sem banco de dados nem sessão; cada requisição é independente.</a:t>
+              <a:t>app.py só liga o servidor e registra as rotas. API REST stateless: sem banco de dados nem sessão.</a:t>
             </a:r>
             <a:endParaRPr lang="en-US" sz="1500" dirty="0"/>
           </a:p>
@@ -11427,7 +11334,7 @@
                   <a:schemeClr val="tx2"/>
                 </a:solidFill>
               </a:rPr>
-              <a:t>O app.py em seis blocos (245 linhas)</a:t>
+              <a:t>O backend em MVC, arquivo por arquivo</a:t>
             </a:r>
             <a:endParaRPr lang="en-US" sz="3400" dirty="0"/>
           </a:p>
@@ -11529,7 +11436,7 @@
                   <a:schemeClr val="tx2"/>
                 </a:solidFill>
               </a:rPr>
-              <a:t>Importações</a:t>
+              <a:t>app.py</a:t>
             </a:r>
             <a:endParaRPr lang="en-US" sz="1800" dirty="0"/>
           </a:p>
@@ -11565,15 +11472,7 @@
                   <a:schemeClr val="tx1"/>
                 </a:solidFill>
               </a:rPr>
-              <a:t>os</a:t>
-            </a:r>
-            <a:r>
-              <a:rPr lang="en-US" sz="1500" dirty="0">
-                <a:solidFill>
-                  <a:schemeClr val="tx1"/>
-                </a:solidFill>
-              </a:rPr>
-              <a:t>, re, json, unicodedata, Flask, CORS, dotenv e o SDK genai</a:t>
+              <a:t>Cria o Flask, liga o CORS e registra as rotas do Controller</a:t>
             </a:r>
             <a:endParaRPr lang="en-US" sz="1500" dirty="0"/>
           </a:p>
@@ -11675,7 +11574,7 @@
                   <a:schemeClr val="tx2"/>
                 </a:solidFill>
               </a:rPr>
-              <a:t>Configuração</a:t>
+              <a:t>Controller</a:t>
             </a:r>
             <a:endParaRPr lang="en-US" sz="1800" dirty="0"/>
           </a:p>
@@ -11707,15 +11606,7 @@
             </a:pPr>
             <a:r>
               <a:rPr lang="en-US" sz="1500" dirty="0"/>
-              <a:t>C</a:t>
-            </a:r>
-            <a:r>
-              <a:rPr lang="en-US" sz="1500" dirty="0">
-                <a:solidFill>
-                  <a:schemeClr val="tx1"/>
-                </a:solidFill>
-              </a:rPr>
-              <a:t>arrega o .env, cria o app com CORS, porta 3001, cliente Gemini e os dois modelos</a:t>
+              <a:t>controllers/receita_controller.py: as 3 rotas e o fluxo de cada requisição</a:t>
             </a:r>
             <a:endParaRPr lang="en-US" sz="1500" dirty="0"/>
           </a:p>
@@ -11817,7 +11708,7 @@
                   <a:schemeClr val="tx2"/>
                 </a:solidFill>
               </a:rPr>
-              <a:t>Validações</a:t>
+              <a:t>Model · regras</a:t>
             </a:r>
             <a:endParaRPr lang="en-US" sz="1800" dirty="0"/>
           </a:p>
@@ -11853,15 +11744,7 @@
                   <a:schemeClr val="tx1"/>
                 </a:solidFill>
               </a:rPr>
-              <a:t>validar_formato_ingredientes</a:t>
-            </a:r>
-            <a:r>
-              <a:rPr lang="en-US" sz="1500" dirty="0">
-                <a:solidFill>
-                  <a:schemeClr val="tx1"/>
-                </a:solidFill>
-              </a:rPr>
-              <a:t>, verificar_erro_cota (429) e verificar_erro_sobrecarga (503)</a:t>
+              <a:t>models/receita_model.py: valida os ingredientes e separa os extras</a:t>
             </a:r>
             <a:endParaRPr lang="en-US" sz="1500" dirty="0"/>
           </a:p>
@@ -11963,7 +11846,7 @@
                   <a:schemeClr val="tx2"/>
                 </a:solidFill>
               </a:rPr>
-              <a:t>Chamada à IA</a:t>
+              <a:t>Model · IA</a:t>
             </a:r>
             <a:endParaRPr lang="en-US" sz="1800" dirty="0"/>
           </a:p>
@@ -11999,31 +11882,7 @@
                   <a:schemeClr val="tx1"/>
                 </a:solidFill>
               </a:rPr>
-              <a:t>chamar_modelo</a:t>
-            </a:r>
-            <a:r>
-              <a:rPr lang="en-US" sz="1500" dirty="0">
-                <a:solidFill>
-                  <a:schemeClr val="tx1"/>
-                </a:solidFill>
-              </a:rPr>
-              <a:t> pede JSON ao Gemini; </a:t>
-            </a:r>
-            <a:r>
-              <a:rPr lang="en-US" sz="1500" dirty="0" err="1">
-                <a:solidFill>
-                  <a:schemeClr val="tx1"/>
-                </a:solidFill>
-              </a:rPr>
-              <a:t>separar_ingredientes_extras</a:t>
-            </a:r>
-            <a:r>
-              <a:rPr lang="en-US" sz="1500" dirty="0">
-                <a:solidFill>
-                  <a:schemeClr val="tx1"/>
-                </a:solidFill>
-              </a:rPr>
-              <a:t> move extras para os opcionais</a:t>
+              <a:t>montar_prompt, chamar_modelo e gerar_receita (principal → reserva)</a:t>
             </a:r>
             <a:endParaRPr lang="en-US" sz="1500" dirty="0"/>
           </a:p>
@@ -12125,7 +11984,7 @@
                   <a:schemeClr val="tx2"/>
                 </a:solidFill>
               </a:rPr>
-              <a:t>Rotas</a:t>
+              <a:t>View</a:t>
             </a:r>
             <a:endParaRPr lang="en-US" sz="1800" dirty="0"/>
           </a:p>
@@ -12161,7 +12020,7 @@
                   <a:schemeClr val="tx1"/>
                 </a:solidFill>
               </a:rPr>
-              <a:t>GET /, GET /api/status e POST /api/receitas/gerar</a:t>
+              <a:t>views/resposta_view.py: monta as respostas em JSON (sucesso e erro)</a:t>
             </a:r>
             <a:endParaRPr lang="en-US" sz="1500" dirty="0"/>
           </a:p>
@@ -12263,7 +12122,7 @@
                   <a:schemeClr val="tx2"/>
                 </a:solidFill>
               </a:rPr>
-              <a:t>Inicialização</a:t>
+              <a:t>Frontend</a:t>
             </a:r>
             <a:endParaRPr lang="en-US" sz="1800" dirty="0"/>
           </a:p>
@@ -12299,7 +12158,7 @@
                   <a:schemeClr val="tx1"/>
                 </a:solidFill>
               </a:rPr>
-              <a:t>app.run(host="0.0.0.0", port=3001, debug=False)</a:t>
+              <a:t>React Native Web: a tela que o usuário vê, alimentada pelo JSON da View</a:t>
             </a:r>
             <a:endParaRPr lang="en-US" sz="1500" dirty="0"/>
           </a:p>

</xml_diff>